<commit_message>
Add cooperation structure slide (s.r.o. 51/49 after first gate)
Co-Authored-By: Claude Fable 5 <noreply@anthropic.com>
Claude-Session: https://claude.ai/code/session_01RB9RhxhjzkwdTXvKJxEWYS
</commit_message>
<xml_diff>
--- a/prezentacie/AI_projekty_Forbes_SK_diskusia.pptx
+++ b/prezentacie/AI_projekty_Forbes_SK_diskusia.pptx
@@ -18,9 +18,10 @@
     <p:sldId id="266" r:id="rId12"/>
     <p:sldId id="267" r:id="rId13"/>
     <p:sldId id="268" r:id="rId14"/>
+    <p:sldId id="269" r:id="rId15"/>
   </p:sldIdLst>
   <p:notesMasterIdLst>
-    <p:notesMasterId r:id="rId15"/>
+    <p:notesMasterId r:id="rId16"/>
   </p:notesMasterIdLst>
   <p:sldSz cx="12192000" cy="6858000"/>
   <p:notesSz cx="6858000" cy="12192000"/>
@@ -890,6 +891,94 @@
             <a:fld id="{F7021451-1387-4CA6-816F-3879F97B5CBC}" type="slidenum">
               <a:rPr lang="en-US"/>
               <a:t>13</a:t>
+            </a:fld>
+            <a:endParaRPr lang="en-US"/>
+          </a:p>
+        </p:txBody>
+      </p:sp>
+    </p:spTree>
+    <p:extLst>
+      <p:ext uri="{BB962C8B-B14F-4D97-AF65-F5344CB8AC3E}">
+        <p14:creationId xmlns:p14="http://schemas.microsoft.com/office/powerpoint/2010/main" val="1024086991"/>
+      </p:ext>
+    </p:extLst>
+  </p:cSld>
+  <p:clrMapOvr>
+    <a:masterClrMapping/>
+  </p:clrMapOvr>
+</p:notes>
+</file>
+
+<file path=ppt/notesSlides/notesSlide14.xml><?xml version="1.0" encoding="utf-8"?>
+<p:notes xmlns:a="http://schemas.openxmlformats.org/drawingml/2006/main" xmlns:r="http://schemas.openxmlformats.org/officeDocument/2006/relationships" xmlns:p="http://schemas.openxmlformats.org/presentationml/2006/main">
+  <p:cSld>
+    <p:spTree>
+      <p:nvGrpSpPr>
+        <p:cNvPr id="1" name=""/>
+        <p:cNvGrpSpPr/>
+        <p:nvPr/>
+      </p:nvGrpSpPr>
+      <p:grpSpPr>
+        <a:xfrm>
+          <a:off x="0" y="0"/>
+          <a:ext cx="0" cy="0"/>
+          <a:chOff x="0" y="0"/>
+          <a:chExt cx="0" cy="0"/>
+        </a:xfrm>
+      </p:grpSpPr>
+      <p:sp>
+        <p:nvSpPr>
+          <p:cNvPr id="2" name="Slide Image Placeholder 1"/>
+          <p:cNvSpPr>
+            <a:spLocks noGrp="1" noRot="1" noChangeAspect="1"/>
+          </p:cNvSpPr>
+          <p:nvPr>
+            <p:ph type="sldImg"/>
+          </p:nvPr>
+        </p:nvSpPr>
+        <p:spPr/>
+      </p:sp>
+      <p:sp>
+        <p:nvSpPr>
+          <p:cNvPr id="3" name="Notes Placeholder 2"/>
+          <p:cNvSpPr>
+            <a:spLocks noGrp="1"/>
+          </p:cNvSpPr>
+          <p:nvPr>
+            <p:ph type="body" idx="1"/>
+          </p:nvPr>
+        </p:nvSpPr>
+        <p:spPr/>
+        <p:txBody>
+          <a:bodyPr/>
+          <a:lstStyle/>
+          <a:p>
+            <a:r>
+              <a:rPr lang="en-US" dirty="0"/>
+              <a:t/>
+            </a:r>
+            <a:endParaRPr lang="en-US" dirty="0"/>
+          </a:p>
+        </p:txBody>
+      </p:sp>
+      <p:sp>
+        <p:nvSpPr>
+          <p:cNvPr id="4" name="Slide Number Placeholder 3"/>
+          <p:cNvSpPr>
+            <a:spLocks noGrp="1"/>
+          </p:cNvSpPr>
+          <p:nvPr>
+            <p:ph type="sldNum" sz="quarter" idx="10"/>
+          </p:nvPr>
+        </p:nvSpPr>
+        <p:spPr/>
+        <p:txBody>
+          <a:bodyPr/>
+          <a:lstStyle/>
+          <a:p>
+            <a:fld id="{F7021451-1387-4CA6-816F-3879F97B5CBC}" type="slidenum">
+              <a:rPr lang="en-US"/>
+              <a:t>14</a:t>
             </a:fld>
             <a:endParaRPr lang="en-US"/>
           </a:p>
@@ -2207,7 +2296,7 @@
         <p:spPr>
           <a:xfrm>
             <a:off x="7452360" y="1417320"/>
-            <a:ext cx="4160520" cy="4480560"/>
+            <a:ext cx="4160520" cy="4892040"/>
           </a:xfrm>
           <a:prstGeom prst="roundRect">
             <a:avLst>
@@ -2379,7 +2468,7 @@
         </p:nvSpPr>
         <p:spPr>
           <a:xfrm>
-            <a:off x="7772400" y="2734056"/>
+            <a:off x="7772400" y="2697480"/>
             <a:ext cx="320040" cy="274320"/>
           </a:xfrm>
           <a:prstGeom prst="rect">
@@ -2418,7 +2507,7 @@
         </p:nvSpPr>
         <p:spPr>
           <a:xfrm>
-            <a:off x="8183880" y="2715768"/>
+            <a:off x="8183880" y="2679192"/>
             <a:ext cx="3246120" cy="566928"/>
           </a:xfrm>
           <a:prstGeom prst="rect">
@@ -2486,7 +2575,7 @@
         </p:nvSpPr>
         <p:spPr>
           <a:xfrm>
-            <a:off x="7772400" y="3346704"/>
+            <a:off x="7772400" y="3273552"/>
             <a:ext cx="320040" cy="274320"/>
           </a:xfrm>
           <a:prstGeom prst="rect">
@@ -2525,7 +2614,7 @@
         </p:nvSpPr>
         <p:spPr>
           <a:xfrm>
-            <a:off x="8183880" y="3328416"/>
+            <a:off x="8183880" y="3255264"/>
             <a:ext cx="3246120" cy="566928"/>
           </a:xfrm>
           <a:prstGeom prst="rect">
@@ -2593,7 +2682,7 @@
         </p:nvSpPr>
         <p:spPr>
           <a:xfrm>
-            <a:off x="7772400" y="3959352"/>
+            <a:off x="7772400" y="3849624"/>
             <a:ext cx="320040" cy="274320"/>
           </a:xfrm>
           <a:prstGeom prst="rect">
@@ -2632,7 +2721,7 @@
         </p:nvSpPr>
         <p:spPr>
           <a:xfrm>
-            <a:off x="8183880" y="3941064"/>
+            <a:off x="8183880" y="3831336"/>
             <a:ext cx="3246120" cy="566928"/>
           </a:xfrm>
           <a:prstGeom prst="rect">
@@ -2700,7 +2789,7 @@
         </p:nvSpPr>
         <p:spPr>
           <a:xfrm>
-            <a:off x="7772400" y="4572000"/>
+            <a:off x="7772400" y="4425696"/>
             <a:ext cx="320040" cy="274320"/>
           </a:xfrm>
           <a:prstGeom prst="rect">
@@ -2739,7 +2828,7 @@
         </p:nvSpPr>
         <p:spPr>
           <a:xfrm>
-            <a:off x="8183880" y="4553712"/>
+            <a:off x="8183880" y="4407408"/>
             <a:ext cx="3246120" cy="566928"/>
           </a:xfrm>
           <a:prstGeom prst="rect">
@@ -2807,7 +2896,7 @@
         </p:nvSpPr>
         <p:spPr>
           <a:xfrm>
-            <a:off x="7772400" y="5184648"/>
+            <a:off x="7772400" y="5001768"/>
             <a:ext cx="320040" cy="274320"/>
           </a:xfrm>
           <a:prstGeom prst="rect">
@@ -2846,7 +2935,114 @@
         </p:nvSpPr>
         <p:spPr>
           <a:xfrm>
-            <a:off x="8183880" y="5166360"/>
+            <a:off x="8183880" y="4983480"/>
+            <a:ext cx="3246120" cy="566928"/>
+          </a:xfrm>
+          <a:prstGeom prst="rect">
+            <a:avLst/>
+          </a:prstGeom>
+          <a:noFill/>
+          <a:ln/>
+        </p:spPr>
+        <p:txBody>
+          <a:bodyPr wrap="square" lIns="0" tIns="0" rIns="0" bIns="0" rtlCol="0" anchor="ctr"/>
+          <a:lstStyle/>
+          <a:p>
+            <a:pPr algn="l" indent="0" marL="0">
+              <a:lnSpc>
+                <a:spcPct val="105000"/>
+              </a:lnSpc>
+              <a:buNone/>
+            </a:pPr>
+            <a:r>
+              <a:rPr lang="en-US" sz="1250" b="1" dirty="0">
+                <a:solidFill>
+                  <a:srgbClr val="F2F6F8"/>
+                </a:solidFill>
+                <a:latin typeface="Calibri" pitchFamily="34" charset="0"/>
+                <a:ea typeface="Calibri" pitchFamily="34" charset="-122"/>
+                <a:cs typeface="Calibri" pitchFamily="34" charset="-120"/>
+              </a:rPr>
+              <a:t>Forma spolupráce</a:t>
+            </a:r>
+            <a:pPr algn="l" indent="0" marL="0">
+              <a:lnSpc>
+                <a:spcPct val="105000"/>
+              </a:lnSpc>
+              <a:buNone/>
+            </a:pPr>
+            <a:endParaRPr lang="en-US" sz="1250" dirty="0"/>
+          </a:p>
+          <a:p>
+            <a:pPr algn="l" indent="0" marL="0">
+              <a:lnSpc>
+                <a:spcPct val="105000"/>
+              </a:lnSpc>
+              <a:buNone/>
+            </a:pPr>
+            <a:r>
+              <a:rPr lang="en-US" sz="1050" dirty="0">
+                <a:solidFill>
+                  <a:srgbClr val="8DA2B2"/>
+                </a:solidFill>
+                <a:latin typeface="Calibri" pitchFamily="34" charset="0"/>
+                <a:ea typeface="Calibri" pitchFamily="34" charset="-122"/>
+                <a:cs typeface="Calibri" pitchFamily="34" charset="-120"/>
+              </a:rPr>
+              <a:t>od prvého gateu: s.r.o., 51 / 49</a:t>
+            </a:r>
+            <a:endParaRPr lang="en-US" sz="1250" dirty="0"/>
+          </a:p>
+        </p:txBody>
+      </p:sp>
+      <p:sp>
+        <p:nvSpPr>
+          <p:cNvPr id="21" name="Text 19"/>
+          <p:cNvSpPr txBox="1"/>
+          <p:nvPr/>
+        </p:nvSpPr>
+        <p:spPr>
+          <a:xfrm>
+            <a:off x="7772400" y="5577840"/>
+            <a:ext cx="320040" cy="274320"/>
+          </a:xfrm>
+          <a:prstGeom prst="rect">
+            <a:avLst/>
+          </a:prstGeom>
+          <a:noFill/>
+          <a:ln/>
+        </p:spPr>
+        <p:txBody>
+          <a:bodyPr wrap="square" lIns="0" tIns="0" rIns="0" bIns="0" rtlCol="0" anchor="ctr"/>
+          <a:lstStyle/>
+          <a:p>
+            <a:pPr algn="l" indent="0" marL="0">
+              <a:buNone/>
+            </a:pPr>
+            <a:r>
+              <a:rPr lang="en-US" sz="1300" b="1" dirty="0">
+                <a:solidFill>
+                  <a:srgbClr val="3FB6E8"/>
+                </a:solidFill>
+                <a:latin typeface="Cambria" pitchFamily="34" charset="0"/>
+                <a:ea typeface="Cambria" pitchFamily="34" charset="-122"/>
+                <a:cs typeface="Cambria" pitchFamily="34" charset="-120"/>
+              </a:rPr>
+              <a:t>7</a:t>
+            </a:r>
+            <a:endParaRPr lang="en-US" sz="1300" dirty="0"/>
+          </a:p>
+        </p:txBody>
+      </p:sp>
+      <p:sp>
+        <p:nvSpPr>
+          <p:cNvPr id="22" name="Text 20"/>
+          <p:cNvSpPr txBox="1"/>
+          <p:nvPr/>
+        </p:nvSpPr>
+        <p:spPr>
+          <a:xfrm>
+            <a:off x="8183880" y="5559552"/>
             <a:ext cx="3246120" cy="566928"/>
           </a:xfrm>
           <a:prstGeom prst="rect">
@@ -6006,6 +6202,697 @@
 <file path=ppt/slides/slide13.xml><?xml version="1.0" encoding="utf-8"?>
 <p:sld xmlns:a="http://schemas.openxmlformats.org/drawingml/2006/main" xmlns:r="http://schemas.openxmlformats.org/officeDocument/2006/relationships" xmlns:p="http://schemas.openxmlformats.org/presentationml/2006/main">
   <p:cSld name="Slide 13">
+    <p:bg>
+      <p:bgPr>
+        <a:solidFill>
+          <a:srgbClr val="0B0F14"/>
+        </a:solidFill>
+      </p:bgPr>
+    </p:bg>
+    <p:spTree>
+      <p:nvGrpSpPr>
+        <p:cNvPr id="1" name=""/>
+        <p:cNvGrpSpPr/>
+        <p:nvPr/>
+      </p:nvGrpSpPr>
+      <p:grpSpPr>
+        <a:xfrm>
+          <a:off x="0" y="0"/>
+          <a:ext cx="0" cy="0"/>
+          <a:chOff x="0" y="0"/>
+          <a:chExt cx="0" cy="0"/>
+        </a:xfrm>
+      </p:grpSpPr>
+      <p:sp>
+        <p:nvSpPr>
+          <p:cNvPr id="2" name="Text 0"/>
+          <p:cNvSpPr txBox="1"/>
+          <p:nvPr/>
+        </p:nvSpPr>
+        <p:spPr>
+          <a:xfrm>
+            <a:off x="566928" y="292608"/>
+            <a:ext cx="2743200" cy="365760"/>
+          </a:xfrm>
+          <a:prstGeom prst="rect">
+            <a:avLst/>
+          </a:prstGeom>
+          <a:noFill/>
+          <a:ln/>
+        </p:spPr>
+        <p:txBody>
+          <a:bodyPr wrap="square" lIns="0" tIns="0" rIns="0" bIns="0" rtlCol="0" anchor="ctr"/>
+          <a:lstStyle/>
+          <a:p>
+            <a:pPr algn="l" indent="0" marL="0">
+              <a:buNone/>
+            </a:pPr>
+            <a:r>
+              <a:rPr lang="en-US" sz="1300" b="1" dirty="0">
+                <a:solidFill>
+                  <a:srgbClr val="F2F6F8"/>
+                </a:solidFill>
+                <a:latin typeface="Calibri" pitchFamily="34" charset="0"/>
+                <a:ea typeface="Calibri" pitchFamily="34" charset="-122"/>
+                <a:cs typeface="Calibri" pitchFamily="34" charset="-120"/>
+              </a:rPr>
+              <a:t>Monetize</a:t>
+            </a:r>
+            <a:pPr algn="l" indent="0" marL="0">
+              <a:buNone/>
+            </a:pPr>
+            <a:r>
+              <a:rPr lang="en-US" sz="1300" b="1" dirty="0">
+                <a:solidFill>
+                  <a:srgbClr val="3FB6E8"/>
+                </a:solidFill>
+                <a:latin typeface="Calibri" pitchFamily="34" charset="0"/>
+                <a:ea typeface="Calibri" pitchFamily="34" charset="-122"/>
+                <a:cs typeface="Calibri" pitchFamily="34" charset="-120"/>
+              </a:rPr>
+              <a:t>.CX</a:t>
+            </a:r>
+            <a:endParaRPr lang="en-US" sz="1300" dirty="0"/>
+          </a:p>
+        </p:txBody>
+      </p:sp>
+      <p:sp>
+        <p:nvSpPr>
+          <p:cNvPr id="3" name="Text 1"/>
+          <p:cNvSpPr txBox="1"/>
+          <p:nvPr/>
+        </p:nvSpPr>
+        <p:spPr>
+          <a:xfrm>
+            <a:off x="585216" y="868680"/>
+            <a:ext cx="10972800" cy="292608"/>
+          </a:xfrm>
+          <a:prstGeom prst="rect">
+            <a:avLst/>
+          </a:prstGeom>
+          <a:noFill/>
+          <a:ln/>
+        </p:spPr>
+        <p:txBody>
+          <a:bodyPr wrap="square" lIns="0" tIns="0" rIns="0" bIns="0" rtlCol="0" anchor="ctr"/>
+          <a:lstStyle/>
+          <a:p>
+            <a:pPr algn="l" indent="0" marL="0">
+              <a:buNone/>
+            </a:pPr>
+            <a:r>
+              <a:rPr lang="en-US" sz="1050" b="1" spc="300" kern="0" dirty="0">
+                <a:solidFill>
+                  <a:srgbClr val="3FB6E8"/>
+                </a:solidFill>
+                <a:latin typeface="Calibri" pitchFamily="34" charset="0"/>
+                <a:ea typeface="Calibri" pitchFamily="34" charset="-122"/>
+                <a:cs typeface="Calibri" pitchFamily="34" charset="-120"/>
+              </a:rPr>
+              <a:t>FORMA SPOLUPRÁCE  ·  LEN PRI RASTOVÝCH PRODUKTOCH</a:t>
+            </a:r>
+            <a:endParaRPr lang="en-US" sz="1050" dirty="0"/>
+          </a:p>
+        </p:txBody>
+      </p:sp>
+      <p:sp>
+        <p:nvSpPr>
+          <p:cNvPr id="4" name="Text 2"/>
+          <p:cNvSpPr txBox="1"/>
+          <p:nvPr/>
+        </p:nvSpPr>
+        <p:spPr>
+          <a:xfrm>
+            <a:off x="566928" y="1207008"/>
+            <a:ext cx="11064240" cy="685800"/>
+          </a:xfrm>
+          <a:prstGeom prst="rect">
+            <a:avLst/>
+          </a:prstGeom>
+          <a:noFill/>
+          <a:ln/>
+        </p:spPr>
+        <p:txBody>
+          <a:bodyPr wrap="square" lIns="0" tIns="0" rIns="0" bIns="0" rtlCol="0" anchor="ctr"/>
+          <a:lstStyle/>
+          <a:p>
+            <a:pPr algn="l" indent="0" marL="0">
+              <a:buNone/>
+            </a:pPr>
+            <a:r>
+              <a:rPr lang="en-US" sz="2600" b="1" dirty="0">
+                <a:solidFill>
+                  <a:srgbClr val="F2F6F8"/>
+                </a:solidFill>
+                <a:latin typeface="Cambria" pitchFamily="34" charset="0"/>
+                <a:ea typeface="Cambria" pitchFamily="34" charset="-122"/>
+                <a:cs typeface="Cambria" pitchFamily="34" charset="-120"/>
+              </a:rPr>
+              <a:t>Najprv pokus. Forma spolupráce až od prvého gateu.</a:t>
+            </a:r>
+            <a:endParaRPr lang="en-US" sz="2600" dirty="0"/>
+          </a:p>
+        </p:txBody>
+      </p:sp>
+      <p:sp>
+        <p:nvSpPr>
+          <p:cNvPr id="5" name="Text 3"/>
+          <p:cNvSpPr txBox="1"/>
+          <p:nvPr/>
+        </p:nvSpPr>
+        <p:spPr>
+          <a:xfrm>
+            <a:off x="566928" y="1828800"/>
+            <a:ext cx="11064240" cy="594360"/>
+          </a:xfrm>
+          <a:prstGeom prst="rect">
+            <a:avLst/>
+          </a:prstGeom>
+          <a:noFill/>
+          <a:ln/>
+        </p:spPr>
+        <p:txBody>
+          <a:bodyPr wrap="square" lIns="0" tIns="0" rIns="0" bIns="0" rtlCol="0" anchor="ctr"/>
+          <a:lstStyle/>
+          <a:p>
+            <a:pPr indent="0" marL="0">
+              <a:lnSpc>
+                <a:spcPct val="110000"/>
+              </a:lnSpc>
+              <a:buNone/>
+            </a:pPr>
+            <a:r>
+              <a:rPr lang="en-US" sz="1250" dirty="0">
+                <a:solidFill>
+                  <a:srgbClr val="8DA2B2"/>
+                </a:solidFill>
+                <a:latin typeface="Calibri" pitchFamily="34" charset="0"/>
+                <a:ea typeface="Calibri" pitchFamily="34" charset="-122"/>
+                <a:cs typeface="Calibri" pitchFamily="34" charset="-120"/>
+              </a:rPr>
+              <a:t>Do momentu, keď prvý pilot prejde gateom, sa nič nezakladá a nič nepodpisuje — presne preto je dnešné rozhodnutie o priestore na pokus, nie o investícii. Až keď metrika sedí, má zmysel baviť sa o štruktúre.</a:t>
+            </a:r>
+            <a:endParaRPr lang="en-US" sz="1250" dirty="0"/>
+          </a:p>
+        </p:txBody>
+      </p:sp>
+      <p:sp>
+        <p:nvSpPr>
+          <p:cNvPr id="6" name="Shape 4"/>
+          <p:cNvSpPr/>
+          <p:nvPr/>
+        </p:nvSpPr>
+        <p:spPr>
+          <a:xfrm>
+            <a:off x="566928" y="2606040"/>
+            <a:ext cx="5440680" cy="3246120"/>
+          </a:xfrm>
+          <a:prstGeom prst="roundRect">
+            <a:avLst>
+              <a:gd name="adj" fmla="val 1972"/>
+            </a:avLst>
+          </a:prstGeom>
+          <a:solidFill>
+            <a:srgbClr val="111C26"/>
+          </a:solidFill>
+          <a:ln w="12700">
+            <a:solidFill>
+              <a:srgbClr val="263A4C"/>
+            </a:solidFill>
+            <a:prstDash val="solid"/>
+          </a:ln>
+        </p:spPr>
+      </p:sp>
+      <p:sp>
+        <p:nvSpPr>
+          <p:cNvPr id="7" name="Text 5"/>
+          <p:cNvSpPr txBox="1"/>
+          <p:nvPr/>
+        </p:nvSpPr>
+        <p:spPr>
+          <a:xfrm>
+            <a:off x="896112" y="2880360"/>
+            <a:ext cx="4754880" cy="256032"/>
+          </a:xfrm>
+          <a:prstGeom prst="rect">
+            <a:avLst/>
+          </a:prstGeom>
+          <a:noFill/>
+          <a:ln/>
+        </p:spPr>
+        <p:txBody>
+          <a:bodyPr wrap="square" lIns="0" tIns="0" rIns="0" bIns="0" rtlCol="0" anchor="ctr"/>
+          <a:lstStyle/>
+          <a:p>
+            <a:pPr algn="l" indent="0" marL="0">
+              <a:buNone/>
+            </a:pPr>
+            <a:r>
+              <a:rPr lang="en-US" sz="950" b="1" spc="250" kern="0" dirty="0">
+                <a:solidFill>
+                  <a:srgbClr val="3FB6E8"/>
+                </a:solidFill>
+                <a:latin typeface="Calibri" pitchFamily="34" charset="0"/>
+                <a:ea typeface="Calibri" pitchFamily="34" charset="-122"/>
+                <a:cs typeface="Calibri" pitchFamily="34" charset="-120"/>
+              </a:rPr>
+              <a:t>KEDY</a:t>
+            </a:r>
+            <a:endParaRPr lang="en-US" sz="950" dirty="0"/>
+          </a:p>
+        </p:txBody>
+      </p:sp>
+      <p:sp>
+        <p:nvSpPr>
+          <p:cNvPr id="8" name="Text 6"/>
+          <p:cNvSpPr txBox="1"/>
+          <p:nvPr/>
+        </p:nvSpPr>
+        <p:spPr>
+          <a:xfrm>
+            <a:off x="896112" y="3246120"/>
+            <a:ext cx="4800600" cy="777240"/>
+          </a:xfrm>
+          <a:prstGeom prst="rect">
+            <a:avLst/>
+          </a:prstGeom>
+          <a:noFill/>
+          <a:ln/>
+        </p:spPr>
+        <p:txBody>
+          <a:bodyPr wrap="square" lIns="0" tIns="0" rIns="0" bIns="0" rtlCol="0" anchor="ctr"/>
+          <a:lstStyle/>
+          <a:p>
+            <a:pPr indent="0" marL="0">
+              <a:lnSpc>
+                <a:spcPct val="105000"/>
+              </a:lnSpc>
+              <a:buNone/>
+            </a:pPr>
+            <a:r>
+              <a:rPr lang="en-US" sz="1250" b="1" dirty="0">
+                <a:solidFill>
+                  <a:srgbClr val="F2F6F8"/>
+                </a:solidFill>
+                <a:latin typeface="Calibri" pitchFamily="34" charset="0"/>
+                <a:ea typeface="Calibri" pitchFamily="34" charset="-122"/>
+                <a:cs typeface="Calibri" pitchFamily="34" charset="-120"/>
+              </a:rPr>
+              <a:t>Teraz</a:t>
+            </a:r>
+            <a:endParaRPr lang="en-US" sz="1250" dirty="0"/>
+          </a:p>
+          <a:p>
+            <a:pPr indent="0" marL="0">
+              <a:lnSpc>
+                <a:spcPct val="105000"/>
+              </a:lnSpc>
+              <a:buNone/>
+            </a:pPr>
+            <a:r>
+              <a:rPr lang="en-US" sz="1100" dirty="0">
+                <a:solidFill>
+                  <a:srgbClr val="8DA2B2"/>
+                </a:solidFill>
+                <a:latin typeface="Calibri" pitchFamily="34" charset="0"/>
+                <a:ea typeface="Calibri" pitchFamily="34" charset="-122"/>
+                <a:cs typeface="Calibri" pitchFamily="34" charset="-120"/>
+              </a:rPr>
+              <a:t>žiadna zmluva, žiadny vklad — piloty bežia na mojej strane, riziko firmy je nulové</a:t>
+            </a:r>
+            <a:endParaRPr lang="en-US" sz="1250" dirty="0"/>
+          </a:p>
+        </p:txBody>
+      </p:sp>
+      <p:sp>
+        <p:nvSpPr>
+          <p:cNvPr id="9" name="Text 7"/>
+          <p:cNvSpPr txBox="1"/>
+          <p:nvPr/>
+        </p:nvSpPr>
+        <p:spPr>
+          <a:xfrm>
+            <a:off x="896112" y="4114800"/>
+            <a:ext cx="4800600" cy="777240"/>
+          </a:xfrm>
+          <a:prstGeom prst="rect">
+            <a:avLst/>
+          </a:prstGeom>
+          <a:noFill/>
+          <a:ln/>
+        </p:spPr>
+        <p:txBody>
+          <a:bodyPr wrap="square" lIns="0" tIns="0" rIns="0" bIns="0" rtlCol="0" anchor="ctr"/>
+          <a:lstStyle/>
+          <a:p>
+            <a:pPr indent="0" marL="0">
+              <a:lnSpc>
+                <a:spcPct val="105000"/>
+              </a:lnSpc>
+              <a:buNone/>
+            </a:pPr>
+            <a:r>
+              <a:rPr lang="en-US" sz="1250" b="1" dirty="0">
+                <a:solidFill>
+                  <a:srgbClr val="39D98A"/>
+                </a:solidFill>
+                <a:latin typeface="Calibri" pitchFamily="34" charset="0"/>
+                <a:ea typeface="Calibri" pitchFamily="34" charset="-122"/>
+                <a:cs typeface="Calibri" pitchFamily="34" charset="-120"/>
+              </a:rPr>
+              <a:t>Pilot prejde gateom</a:t>
+            </a:r>
+            <a:endParaRPr lang="en-US" sz="1250" dirty="0"/>
+          </a:p>
+          <a:p>
+            <a:pPr indent="0" marL="0">
+              <a:lnSpc>
+                <a:spcPct val="105000"/>
+              </a:lnSpc>
+              <a:buNone/>
+            </a:pPr>
+            <a:r>
+              <a:rPr lang="en-US" sz="1100" dirty="0">
+                <a:solidFill>
+                  <a:srgbClr val="8DA2B2"/>
+                </a:solidFill>
+                <a:latin typeface="Calibri" pitchFamily="34" charset="0"/>
+                <a:ea typeface="Calibri" pitchFamily="34" charset="-122"/>
+                <a:cs typeface="Calibri" pitchFamily="34" charset="-120"/>
+              </a:rPr>
+              <a:t>dohodneme formu spolupráce — najskôr Peritora, potom Splato</a:t>
+            </a:r>
+            <a:endParaRPr lang="en-US" sz="1250" dirty="0"/>
+          </a:p>
+        </p:txBody>
+      </p:sp>
+      <p:sp>
+        <p:nvSpPr>
+          <p:cNvPr id="10" name="Text 8"/>
+          <p:cNvSpPr txBox="1"/>
+          <p:nvPr/>
+        </p:nvSpPr>
+        <p:spPr>
+          <a:xfrm>
+            <a:off x="896112" y="4983480"/>
+            <a:ext cx="4800600" cy="777240"/>
+          </a:xfrm>
+          <a:prstGeom prst="rect">
+            <a:avLst/>
+          </a:prstGeom>
+          <a:noFill/>
+          <a:ln/>
+        </p:spPr>
+        <p:txBody>
+          <a:bodyPr wrap="square" lIns="0" tIns="0" rIns="0" bIns="0" rtlCol="0" anchor="ctr"/>
+          <a:lstStyle/>
+          <a:p>
+            <a:pPr indent="0" marL="0">
+              <a:lnSpc>
+                <a:spcPct val="105000"/>
+              </a:lnSpc>
+              <a:buNone/>
+            </a:pPr>
+            <a:r>
+              <a:rPr lang="en-US" sz="1250" b="1" dirty="0">
+                <a:solidFill>
+                  <a:srgbClr val="F2F6F8"/>
+                </a:solidFill>
+                <a:latin typeface="Calibri" pitchFamily="34" charset="0"/>
+                <a:ea typeface="Calibri" pitchFamily="34" charset="-122"/>
+                <a:cs typeface="Calibri" pitchFamily="34" charset="-120"/>
+              </a:rPr>
+              <a:t>Od založenia</a:t>
+            </a:r>
+            <a:endParaRPr lang="en-US" sz="1250" dirty="0"/>
+          </a:p>
+          <a:p>
+            <a:pPr indent="0" marL="0">
+              <a:lnSpc>
+                <a:spcPct val="105000"/>
+              </a:lnSpc>
+              <a:buNone/>
+            </a:pPr>
+            <a:r>
+              <a:rPr lang="en-US" sz="1100" dirty="0">
+                <a:solidFill>
+                  <a:srgbClr val="8DA2B2"/>
+                </a:solidFill>
+                <a:latin typeface="Calibri" pitchFamily="34" charset="0"/>
+                <a:ea typeface="Calibri" pitchFamily="34" charset="-122"/>
+                <a:cs typeface="Calibri" pitchFamily="34" charset="-120"/>
+              </a:rPr>
+              <a:t>vlastný P&amp;L a vlastná databáza od prvého eura — podmienka oddeliteľnosti a exitu</a:t>
+            </a:r>
+            <a:endParaRPr lang="en-US" sz="1250" dirty="0"/>
+          </a:p>
+        </p:txBody>
+      </p:sp>
+      <p:sp>
+        <p:nvSpPr>
+          <p:cNvPr id="11" name="Shape 9"/>
+          <p:cNvSpPr/>
+          <p:nvPr/>
+        </p:nvSpPr>
+        <p:spPr>
+          <a:xfrm>
+            <a:off x="6190488" y="2606040"/>
+            <a:ext cx="5440680" cy="3246120"/>
+          </a:xfrm>
+          <a:prstGeom prst="roundRect">
+            <a:avLst>
+              <a:gd name="adj" fmla="val 1972"/>
+            </a:avLst>
+          </a:prstGeom>
+          <a:solidFill>
+            <a:srgbClr val="111C26"/>
+          </a:solidFill>
+          <a:ln w="12700">
+            <a:solidFill>
+              <a:srgbClr val="263A4C"/>
+            </a:solidFill>
+            <a:prstDash val="solid"/>
+          </a:ln>
+        </p:spPr>
+      </p:sp>
+      <p:sp>
+        <p:nvSpPr>
+          <p:cNvPr id="12" name="Text 10"/>
+          <p:cNvSpPr txBox="1"/>
+          <p:nvPr/>
+        </p:nvSpPr>
+        <p:spPr>
+          <a:xfrm>
+            <a:off x="6519672" y="2880360"/>
+            <a:ext cx="4754880" cy="256032"/>
+          </a:xfrm>
+          <a:prstGeom prst="rect">
+            <a:avLst/>
+          </a:prstGeom>
+          <a:noFill/>
+          <a:ln/>
+        </p:spPr>
+        <p:txBody>
+          <a:bodyPr wrap="square" lIns="0" tIns="0" rIns="0" bIns="0" rtlCol="0" anchor="ctr"/>
+          <a:lstStyle/>
+          <a:p>
+            <a:pPr algn="l" indent="0" marL="0">
+              <a:buNone/>
+            </a:pPr>
+            <a:r>
+              <a:rPr lang="en-US" sz="950" b="1" spc="250" kern="0" dirty="0">
+                <a:solidFill>
+                  <a:srgbClr val="3FB6E8"/>
+                </a:solidFill>
+                <a:latin typeface="Calibri" pitchFamily="34" charset="0"/>
+                <a:ea typeface="Calibri" pitchFamily="34" charset="-122"/>
+                <a:cs typeface="Calibri" pitchFamily="34" charset="-120"/>
+              </a:rPr>
+              <a:t>AKO — NÁVRH NA DISKUSIU</a:t>
+            </a:r>
+            <a:endParaRPr lang="en-US" sz="950" dirty="0"/>
+          </a:p>
+        </p:txBody>
+      </p:sp>
+      <p:sp>
+        <p:nvSpPr>
+          <p:cNvPr id="13" name="Text 11"/>
+          <p:cNvSpPr txBox="1"/>
+          <p:nvPr/>
+        </p:nvSpPr>
+        <p:spPr>
+          <a:xfrm>
+            <a:off x="6519672" y="3246120"/>
+            <a:ext cx="4892040" cy="2377440"/>
+          </a:xfrm>
+          <a:prstGeom prst="rect">
+            <a:avLst/>
+          </a:prstGeom>
+          <a:noFill/>
+          <a:ln/>
+        </p:spPr>
+        <p:txBody>
+          <a:bodyPr wrap="square" lIns="0" tIns="0" rIns="0" bIns="0" rtlCol="0" anchor="ctr"/>
+          <a:lstStyle/>
+          <a:p>
+            <a:pPr indent="0" marL="0">
+              <a:lnSpc>
+                <a:spcPct val="105000"/>
+              </a:lnSpc>
+              <a:spcAft>
+                <a:spcPts val="600"/>
+              </a:spcAft>
+              <a:buNone/>
+            </a:pPr>
+            <a:r>
+              <a:rPr lang="en-US" sz="1400" b="1" dirty="0">
+                <a:solidFill>
+                  <a:srgbClr val="F2F6F8"/>
+                </a:solidFill>
+                <a:latin typeface="Calibri" pitchFamily="34" charset="0"/>
+                <a:ea typeface="Calibri" pitchFamily="34" charset="-122"/>
+                <a:cs typeface="Calibri" pitchFamily="34" charset="-120"/>
+              </a:rPr>
+              <a:t>Nová s.r.o. pre produkt, 51 % Forbes / 49 % Monetize.CX</a:t>
+            </a:r>
+            <a:endParaRPr lang="en-US" sz="1150" dirty="0"/>
+          </a:p>
+          <a:p>
+            <a:pPr indent="0" marL="0">
+              <a:lnSpc>
+                <a:spcPct val="105000"/>
+              </a:lnSpc>
+              <a:spcAft>
+                <a:spcPts val="600"/>
+              </a:spcAft>
+              <a:buNone/>
+            </a:pPr>
+            <a:endParaRPr lang="en-US" sz="1150" dirty="0"/>
+          </a:p>
+          <a:p>
+            <a:pPr marL="342900" indent="-342900">
+              <a:lnSpc>
+                <a:spcPct val="105000"/>
+              </a:lnSpc>
+              <a:spcAft>
+                <a:spcPts val="600"/>
+              </a:spcAft>
+              <a:buSzPct val="100000"/>
+              <a:buChar char="–"/>
+            </a:pPr>
+            <a:r>
+              <a:rPr lang="en-US" sz="1150" dirty="0">
+                <a:solidFill>
+                  <a:srgbClr val="8DA2B2"/>
+                </a:solidFill>
+                <a:latin typeface="Calibri" pitchFamily="34" charset="0"/>
+                <a:ea typeface="Calibri" pitchFamily="34" charset="-122"/>
+                <a:cs typeface="Calibri" pitchFamily="34" charset="-120"/>
+              </a:rPr>
+              <a:t>Forbes má kontrolu aj väčšinu upside-u; ja mám skin in the game.</a:t>
+            </a:r>
+            <a:endParaRPr lang="en-US" sz="1150" dirty="0"/>
+          </a:p>
+          <a:p>
+            <a:pPr marL="342900" indent="-342900">
+              <a:lnSpc>
+                <a:spcPct val="105000"/>
+              </a:lnSpc>
+              <a:spcAft>
+                <a:spcPts val="600"/>
+              </a:spcAft>
+              <a:buSzPct val="100000"/>
+              <a:buChar char="–"/>
+            </a:pPr>
+            <a:r>
+              <a:rPr lang="en-US" sz="1150" dirty="0">
+                <a:solidFill>
+                  <a:srgbClr val="8DA2B2"/>
+                </a:solidFill>
+                <a:latin typeface="Calibri" pitchFamily="34" charset="0"/>
+                <a:ea typeface="Calibri" pitchFamily="34" charset="-122"/>
+                <a:cs typeface="Calibri" pitchFamily="34" charset="-120"/>
+              </a:rPr>
+              <a:t>Vklad Forbesu: značka a distribúcia. Môj vklad: produkt, metodika, prevádzka.</a:t>
+            </a:r>
+            <a:endParaRPr lang="en-US" sz="1150" dirty="0"/>
+          </a:p>
+          <a:p>
+            <a:pPr marL="342900" indent="-342900">
+              <a:lnSpc>
+                <a:spcPct val="105000"/>
+              </a:lnSpc>
+              <a:spcAft>
+                <a:spcPts val="600"/>
+              </a:spcAft>
+              <a:buSzPct val="100000"/>
+              <a:buChar char="–"/>
+            </a:pPr>
+            <a:r>
+              <a:rPr lang="en-US" sz="1150" dirty="0">
+                <a:solidFill>
+                  <a:srgbClr val="8DA2B2"/>
+                </a:solidFill>
+                <a:latin typeface="Calibri" pitchFamily="34" charset="0"/>
+                <a:ea typeface="Calibri" pitchFamily="34" charset="-122"/>
+                <a:cs typeface="Calibri" pitchFamily="34" charset="-120"/>
+              </a:rPr>
+              <a:t>Pri exite sa predáva s.r.o. — preto tri produkty znamenajú tri nezávislé exity.</a:t>
+            </a:r>
+            <a:endParaRPr lang="en-US" sz="1150" dirty="0"/>
+          </a:p>
+        </p:txBody>
+      </p:sp>
+      <p:sp>
+        <p:nvSpPr>
+          <p:cNvPr id="14" name="Text 12"/>
+          <p:cNvSpPr txBox="1"/>
+          <p:nvPr/>
+        </p:nvSpPr>
+        <p:spPr>
+          <a:xfrm>
+            <a:off x="566928" y="6172200"/>
+            <a:ext cx="11064240" cy="365760"/>
+          </a:xfrm>
+          <a:prstGeom prst="rect">
+            <a:avLst/>
+          </a:prstGeom>
+          <a:noFill/>
+          <a:ln/>
+        </p:spPr>
+        <p:txBody>
+          <a:bodyPr wrap="square" lIns="0" tIns="0" rIns="0" bIns="0" rtlCol="0" anchor="ctr"/>
+          <a:lstStyle/>
+          <a:p>
+            <a:pPr algn="ctr" indent="0" marL="0">
+              <a:buNone/>
+            </a:pPr>
+            <a:r>
+              <a:rPr lang="en-US" sz="1400" i="1" dirty="0">
+                <a:solidFill>
+                  <a:srgbClr val="F2F6F8"/>
+                </a:solidFill>
+                <a:latin typeface="Cambria" pitchFamily="34" charset="0"/>
+                <a:ea typeface="Cambria" pitchFamily="34" charset="-122"/>
+                <a:cs typeface="Cambria" pitchFamily="34" charset="-120"/>
+              </a:rPr>
+              <a:t>Pomer 51 / 49 a presné podmienky = bod na diskusiu 4. 9. — návrh, nie podmienka.</a:t>
+            </a:r>
+            <a:endParaRPr lang="en-US" sz="1400" dirty="0"/>
+          </a:p>
+        </p:txBody>
+      </p:sp>
+    </p:spTree>
+  </p:cSld>
+  <p:clrMapOvr>
+    <a:masterClrMapping/>
+  </p:clrMapOvr>
+</p:sld>
+</file>
+
+<file path=ppt/slides/slide14.xml><?xml version="1.0" encoding="utf-8"?>
+<p:sld xmlns:a="http://schemas.openxmlformats.org/drawingml/2006/main" xmlns:r="http://schemas.openxmlformats.org/officeDocument/2006/relationships" xmlns:p="http://schemas.openxmlformats.org/presentationml/2006/main">
+  <p:cSld name="Slide 14">
     <p:bg>
       <p:bgPr>
         <a:solidFill>

</xml_diff>